<commit_message>
Poster iteration 2: Fix chart annotations, equalize column spacing, fix glyph warnings
</commit_message>
<xml_diff>
--- a/poster/poster_final.pptx
+++ b/poster/poster_final.pptx
@@ -3977,7 +3977,7 @@
         <p:spPr>
           <a:xfrm>
             <a:off x="700000" y="3620000"/>
-            <a:ext cx="8456500" cy="3500000"/>
+            <a:ext cx="8456500" cy="3650000"/>
           </a:xfrm>
           <a:prstGeom prst="roundRect">
             <a:avLst>
@@ -4024,7 +4024,7 @@
         <p:spPr>
           <a:xfrm>
             <a:off x="900000" y="3740000"/>
-            <a:ext cx="8056500" cy="3300000"/>
+            <a:ext cx="8056500" cy="3450000"/>
           </a:xfrm>
           <a:prstGeom prst="rect">
             <a:avLst/>
@@ -4236,7 +4236,7 @@
         </p:nvSpPr>
         <p:spPr>
           <a:xfrm>
-            <a:off x="700000" y="7320000"/>
+            <a:off x="700000" y="7470000"/>
             <a:ext cx="8456500" cy="720000"/>
           </a:xfrm>
           <a:prstGeom prst="rect">
@@ -4279,7 +4279,7 @@
         </p:nvSpPr>
         <p:spPr>
           <a:xfrm>
-            <a:off x="700000" y="7320000"/>
+            <a:off x="700000" y="7470000"/>
             <a:ext cx="90000" cy="720000"/>
           </a:xfrm>
           <a:prstGeom prst="rect">
@@ -4322,7 +4322,7 @@
         </p:nvSpPr>
         <p:spPr>
           <a:xfrm>
-            <a:off x="830000" y="7410000"/>
+            <a:off x="830000" y="7560000"/>
             <a:ext cx="400000" cy="540000"/>
           </a:xfrm>
           <a:prstGeom prst="rect">
@@ -4367,7 +4367,7 @@
         </p:nvSpPr>
         <p:spPr>
           <a:xfrm>
-            <a:off x="1150000" y="7430000"/>
+            <a:off x="1150000" y="7580000"/>
             <a:ext cx="8106500" cy="500000"/>
           </a:xfrm>
           <a:prstGeom prst="rect">
@@ -4412,7 +4412,7 @@
         </p:nvSpPr>
         <p:spPr>
           <a:xfrm>
-            <a:off x="700000" y="7990000"/>
+            <a:off x="700000" y="8140000"/>
             <a:ext cx="8456500" cy="50000"/>
           </a:xfrm>
           <a:prstGeom prst="rect">
@@ -4455,8 +4455,8 @@
         </p:nvSpPr>
         <p:spPr>
           <a:xfrm>
-            <a:off x="700000" y="8040000"/>
-            <a:ext cx="8456500" cy="3200000"/>
+            <a:off x="700000" y="8190000"/>
+            <a:ext cx="8456500" cy="3350000"/>
           </a:xfrm>
           <a:prstGeom prst="roundRect">
             <a:avLst>
@@ -4502,8 +4502,8 @@
         </p:nvSpPr>
         <p:spPr>
           <a:xfrm>
-            <a:off x="900000" y="8160000"/>
-            <a:ext cx="8056500" cy="3000000"/>
+            <a:off x="900000" y="8310000"/>
+            <a:ext cx="8056500" cy="3150000"/>
           </a:xfrm>
           <a:prstGeom prst="rect">
             <a:avLst/>
@@ -4774,7 +4774,7 @@
         </p:nvSpPr>
         <p:spPr>
           <a:xfrm>
-            <a:off x="700000" y="11440000"/>
+            <a:off x="700000" y="11740000"/>
             <a:ext cx="8456500" cy="720000"/>
           </a:xfrm>
           <a:prstGeom prst="rect">
@@ -4817,7 +4817,7 @@
         </p:nvSpPr>
         <p:spPr>
           <a:xfrm>
-            <a:off x="700000" y="11440000"/>
+            <a:off x="700000" y="11740000"/>
             <a:ext cx="90000" cy="720000"/>
           </a:xfrm>
           <a:prstGeom prst="rect">
@@ -4860,7 +4860,7 @@
         </p:nvSpPr>
         <p:spPr>
           <a:xfrm>
-            <a:off x="830000" y="11530000"/>
+            <a:off x="830000" y="11830000"/>
             <a:ext cx="400000" cy="540000"/>
           </a:xfrm>
           <a:prstGeom prst="rect">
@@ -4905,7 +4905,7 @@
         </p:nvSpPr>
         <p:spPr>
           <a:xfrm>
-            <a:off x="1150000" y="11550000"/>
+            <a:off x="1150000" y="11850000"/>
             <a:ext cx="8106500" cy="500000"/>
           </a:xfrm>
           <a:prstGeom prst="rect">
@@ -4950,7 +4950,7 @@
         </p:nvSpPr>
         <p:spPr>
           <a:xfrm>
-            <a:off x="700000" y="12110000"/>
+            <a:off x="700000" y="12410000"/>
             <a:ext cx="8456500" cy="50000"/>
           </a:xfrm>
           <a:prstGeom prst="rect">
@@ -4993,8 +4993,8 @@
         </p:nvSpPr>
         <p:spPr>
           <a:xfrm>
-            <a:off x="700000" y="12160000"/>
-            <a:ext cx="8456500" cy="3100000"/>
+            <a:off x="700000" y="12460000"/>
+            <a:ext cx="8456500" cy="3200000"/>
           </a:xfrm>
           <a:prstGeom prst="roundRect">
             <a:avLst>
@@ -5040,8 +5040,8 @@
         </p:nvSpPr>
         <p:spPr>
           <a:xfrm>
-            <a:off x="900000" y="12280000"/>
-            <a:ext cx="8056500" cy="2900000"/>
+            <a:off x="900000" y="12580000"/>
+            <a:ext cx="8056500" cy="3000000"/>
           </a:xfrm>
           <a:prstGeom prst="rect">
             <a:avLst/>

</xml_diff>

<commit_message>
Poster iteration 3: Add key results highlight strip, balance column heights
</commit_message>
<xml_diff>
--- a/poster/poster_final.pptx
+++ b/poster/poster_final.pptx
@@ -3370,8 +3370,315 @@
         </p:nvSpPr>
         <p:spPr>
           <a:xfrm>
-            <a:off x="600000" y="2200000"/>
-            <a:ext cx="50000" cy="50000"/>
+            <a:off x="0" y="2650000"/>
+            <a:ext cx="36576000" cy="350000"/>
+          </a:xfrm>
+          <a:prstGeom prst="rect">
+            <a:avLst/>
+          </a:prstGeom>
+          <a:solidFill>
+            <a:srgbClr val="E8EBF0"/>
+          </a:solidFill>
+          <a:ln>
+            <a:noFill/>
+          </a:ln>
+        </p:spPr>
+        <p:style>
+          <a:lnRef idx="1">
+            <a:schemeClr val="accent1"/>
+          </a:lnRef>
+          <a:fillRef idx="3">
+            <a:schemeClr val="accent1"/>
+          </a:fillRef>
+          <a:effectRef idx="2">
+            <a:schemeClr val="accent1"/>
+          </a:effectRef>
+          <a:fontRef idx="minor">
+            <a:schemeClr val="lt1"/>
+          </a:fontRef>
+        </p:style>
+        <p:txBody>
+          <a:bodyPr rtlCol="0" anchor="ctr"/>
+          <a:lstStyle/>
+          <a:p>
+            <a:pPr algn="ctr"/>
+          </a:p>
+        </p:txBody>
+      </p:sp>
+      <p:sp>
+        <p:nvSpPr>
+          <p:cNvPr id="9" name="TextBox 8"/>
+          <p:cNvSpPr txBox="1"/>
+          <p:nvPr/>
+        </p:nvSpPr>
+        <p:spPr>
+          <a:xfrm>
+            <a:off x="3000000" y="2700000"/>
+            <a:ext cx="12000000" cy="250000"/>
+          </a:xfrm>
+          <a:prstGeom prst="rect">
+            <a:avLst/>
+          </a:prstGeom>
+          <a:noFill/>
+        </p:spPr>
+        <p:txBody>
+          <a:bodyPr wrap="square">
+            <a:spAutoFit/>
+          </a:bodyPr>
+          <a:lstStyle/>
+          <a:p>
+            <a:pPr algn="ctr">
+              <a:lnSpc>
+                <a:spcPct val="115000"/>
+              </a:lnSpc>
+              <a:spcBef>
+                <a:spcPts val="0"/>
+              </a:spcBef>
+              <a:spcAft>
+                <a:spcPts val="400"/>
+              </a:spcAft>
+            </a:pPr>
+            <a:r>
+              <a:rPr sz="2600" b="1">
+                <a:solidFill>
+                  <a:srgbClr val="27AE60"/>
+                </a:solidFill>
+                <a:latin typeface="Calibri"/>
+              </a:rPr>
+              <a:t>Sol 1 (Cat A): </a:t>
+            </a:r>
+            <a:r>
+              <a:rPr sz="3000" b="1">
+                <a:solidFill>
+                  <a:srgbClr val="27AE60"/>
+                </a:solidFill>
+                <a:latin typeface="Calibri"/>
+              </a:rPr>
+              <a:t>F1 = 0.7340</a:t>
+            </a:r>
+            <a:r>
+              <a:rPr sz="2200" b="0">
+                <a:solidFill>
+                  <a:srgbClr val="666666"/>
+                </a:solidFill>
+                <a:latin typeface="Calibri"/>
+              </a:rPr>
+              <a:t>  (+30.8% vs SVM)</a:t>
+            </a:r>
+          </a:p>
+        </p:txBody>
+      </p:sp>
+      <p:sp>
+        <p:nvSpPr>
+          <p:cNvPr id="10" name="TextBox 9"/>
+          <p:cNvSpPr txBox="1"/>
+          <p:nvPr/>
+        </p:nvSpPr>
+        <p:spPr>
+          <a:xfrm>
+            <a:off x="21000000" y="2700000"/>
+            <a:ext cx="14000000" cy="250000"/>
+          </a:xfrm>
+          <a:prstGeom prst="rect">
+            <a:avLst/>
+          </a:prstGeom>
+          <a:noFill/>
+        </p:spPr>
+        <p:txBody>
+          <a:bodyPr wrap="square">
+            <a:spAutoFit/>
+          </a:bodyPr>
+          <a:lstStyle/>
+          <a:p>
+            <a:pPr algn="ctr">
+              <a:lnSpc>
+                <a:spcPct val="115000"/>
+              </a:lnSpc>
+              <a:spcBef>
+                <a:spcPts val="0"/>
+              </a:spcBef>
+              <a:spcAft>
+                <a:spcPts val="400"/>
+              </a:spcAft>
+            </a:pPr>
+            <a:r>
+              <a:rPr sz="2600" b="1">
+                <a:solidFill>
+                  <a:srgbClr val="E67E22"/>
+                </a:solidFill>
+                <a:latin typeface="Calibri"/>
+              </a:rPr>
+              <a:t>Sol 2 (Cat B): </a:t>
+            </a:r>
+            <a:r>
+              <a:rPr sz="3000" b="1">
+                <a:solidFill>
+                  <a:srgbClr val="E67E22"/>
+                </a:solidFill>
+                <a:latin typeface="Calibri"/>
+              </a:rPr>
+              <a:t>F1 = 0.7422</a:t>
+            </a:r>
+            <a:r>
+              <a:rPr sz="2200" b="0">
+                <a:solidFill>
+                  <a:srgbClr val="666666"/>
+                </a:solidFill>
+                <a:latin typeface="Calibri"/>
+              </a:rPr>
+              <a:t>  (+19.2% vs LSTM)</a:t>
+            </a:r>
+            <a:r>
+              <a:rPr sz="2000" b="0" i="1">
+                <a:solidFill>
+                  <a:srgbClr val="BBBBBB"/>
+                </a:solidFill>
+                <a:latin typeface="Calibri"/>
+              </a:rPr>
+              <a:t>    Both p &lt; 0.001 ***</a:t>
+            </a:r>
+          </a:p>
+        </p:txBody>
+      </p:sp>
+      <p:sp>
+        <p:nvSpPr>
+          <p:cNvPr id="11" name="Rectangle 10"/>
+          <p:cNvSpPr/>
+          <p:nvPr/>
+        </p:nvSpPr>
+        <p:spPr>
+          <a:xfrm>
+            <a:off x="9381500" y="3150000"/>
+            <a:ext cx="15000" cy="12550000"/>
+          </a:xfrm>
+          <a:prstGeom prst="rect">
+            <a:avLst/>
+          </a:prstGeom>
+          <a:solidFill>
+            <a:srgbClr val="DDDDDD"/>
+          </a:solidFill>
+          <a:ln>
+            <a:noFill/>
+          </a:ln>
+        </p:spPr>
+        <p:style>
+          <a:lnRef idx="1">
+            <a:schemeClr val="accent1"/>
+          </a:lnRef>
+          <a:fillRef idx="3">
+            <a:schemeClr val="accent1"/>
+          </a:fillRef>
+          <a:effectRef idx="2">
+            <a:schemeClr val="accent1"/>
+          </a:effectRef>
+          <a:fontRef idx="minor">
+            <a:schemeClr val="lt1"/>
+          </a:fontRef>
+        </p:style>
+        <p:txBody>
+          <a:bodyPr rtlCol="0" anchor="ctr"/>
+          <a:lstStyle/>
+          <a:p>
+            <a:pPr algn="ctr"/>
+          </a:p>
+        </p:txBody>
+      </p:sp>
+      <p:sp>
+        <p:nvSpPr>
+          <p:cNvPr id="12" name="Rectangle 11"/>
+          <p:cNvSpPr/>
+          <p:nvPr/>
+        </p:nvSpPr>
+        <p:spPr>
+          <a:xfrm>
+            <a:off x="18288000" y="3150000"/>
+            <a:ext cx="15000" cy="12550000"/>
+          </a:xfrm>
+          <a:prstGeom prst="rect">
+            <a:avLst/>
+          </a:prstGeom>
+          <a:solidFill>
+            <a:srgbClr val="DDDDDD"/>
+          </a:solidFill>
+          <a:ln>
+            <a:noFill/>
+          </a:ln>
+        </p:spPr>
+        <p:style>
+          <a:lnRef idx="1">
+            <a:schemeClr val="accent1"/>
+          </a:lnRef>
+          <a:fillRef idx="3">
+            <a:schemeClr val="accent1"/>
+          </a:fillRef>
+          <a:effectRef idx="2">
+            <a:schemeClr val="accent1"/>
+          </a:effectRef>
+          <a:fontRef idx="minor">
+            <a:schemeClr val="lt1"/>
+          </a:fontRef>
+        </p:style>
+        <p:txBody>
+          <a:bodyPr rtlCol="0" anchor="ctr"/>
+          <a:lstStyle/>
+          <a:p>
+            <a:pPr algn="ctr"/>
+          </a:p>
+        </p:txBody>
+      </p:sp>
+      <p:sp>
+        <p:nvSpPr>
+          <p:cNvPr id="13" name="Rectangle 12"/>
+          <p:cNvSpPr/>
+          <p:nvPr/>
+        </p:nvSpPr>
+        <p:spPr>
+          <a:xfrm>
+            <a:off x="27194500" y="3150000"/>
+            <a:ext cx="15000" cy="12550000"/>
+          </a:xfrm>
+          <a:prstGeom prst="rect">
+            <a:avLst/>
+          </a:prstGeom>
+          <a:solidFill>
+            <a:srgbClr val="DDDDDD"/>
+          </a:solidFill>
+          <a:ln>
+            <a:noFill/>
+          </a:ln>
+        </p:spPr>
+        <p:style>
+          <a:lnRef idx="1">
+            <a:schemeClr val="accent1"/>
+          </a:lnRef>
+          <a:fillRef idx="3">
+            <a:schemeClr val="accent1"/>
+          </a:fillRef>
+          <a:effectRef idx="2">
+            <a:schemeClr val="accent1"/>
+          </a:effectRef>
+          <a:fontRef idx="minor">
+            <a:schemeClr val="lt1"/>
+          </a:fontRef>
+        </p:style>
+        <p:txBody>
+          <a:bodyPr rtlCol="0" anchor="ctr"/>
+          <a:lstStyle/>
+          <a:p>
+            <a:pPr algn="ctr"/>
+          </a:p>
+        </p:txBody>
+      </p:sp>
+      <p:sp>
+        <p:nvSpPr>
+          <p:cNvPr id="14" name="Rectangle 13"/>
+          <p:cNvSpPr/>
+          <p:nvPr/>
+        </p:nvSpPr>
+        <p:spPr>
+          <a:xfrm>
+            <a:off x="700000" y="3150000"/>
+            <a:ext cx="8456500" cy="720000"/>
           </a:xfrm>
           <a:prstGeom prst="rect">
             <a:avLst/>
@@ -3407,400 +3714,13 @@
       </p:sp>
       <p:sp>
         <p:nvSpPr>
-          <p:cNvPr id="9" name="Rectangle 8"/>
-          <p:cNvSpPr/>
-          <p:nvPr/>
-        </p:nvSpPr>
-        <p:spPr>
-          <a:xfrm>
-            <a:off x="800000" y="2200000"/>
-            <a:ext cx="50000" cy="50000"/>
-          </a:xfrm>
-          <a:prstGeom prst="rect">
-            <a:avLst/>
-          </a:prstGeom>
-          <a:solidFill>
-            <a:srgbClr val="2E86AB"/>
-          </a:solidFill>
-          <a:ln>
-            <a:noFill/>
-          </a:ln>
-        </p:spPr>
-        <p:style>
-          <a:lnRef idx="1">
-            <a:schemeClr val="accent1"/>
-          </a:lnRef>
-          <a:fillRef idx="3">
-            <a:schemeClr val="accent1"/>
-          </a:fillRef>
-          <a:effectRef idx="2">
-            <a:schemeClr val="accent1"/>
-          </a:effectRef>
-          <a:fontRef idx="minor">
-            <a:schemeClr val="lt1"/>
-          </a:fontRef>
-        </p:style>
-        <p:txBody>
-          <a:bodyPr rtlCol="0" anchor="ctr"/>
-          <a:lstStyle/>
-          <a:p>
-            <a:pPr algn="ctr"/>
-          </a:p>
-        </p:txBody>
-      </p:sp>
-      <p:sp>
-        <p:nvSpPr>
-          <p:cNvPr id="10" name="Rectangle 9"/>
-          <p:cNvSpPr/>
-          <p:nvPr/>
-        </p:nvSpPr>
-        <p:spPr>
-          <a:xfrm>
-            <a:off x="1000000" y="2200000"/>
-            <a:ext cx="50000" cy="50000"/>
-          </a:xfrm>
-          <a:prstGeom prst="rect">
-            <a:avLst/>
-          </a:prstGeom>
-          <a:solidFill>
-            <a:srgbClr val="2E86AB"/>
-          </a:solidFill>
-          <a:ln>
-            <a:noFill/>
-          </a:ln>
-        </p:spPr>
-        <p:style>
-          <a:lnRef idx="1">
-            <a:schemeClr val="accent1"/>
-          </a:lnRef>
-          <a:fillRef idx="3">
-            <a:schemeClr val="accent1"/>
-          </a:fillRef>
-          <a:effectRef idx="2">
-            <a:schemeClr val="accent1"/>
-          </a:effectRef>
-          <a:fontRef idx="minor">
-            <a:schemeClr val="lt1"/>
-          </a:fontRef>
-        </p:style>
-        <p:txBody>
-          <a:bodyPr rtlCol="0" anchor="ctr"/>
-          <a:lstStyle/>
-          <a:p>
-            <a:pPr algn="ctr"/>
-          </a:p>
-        </p:txBody>
-      </p:sp>
-      <p:sp>
-        <p:nvSpPr>
-          <p:cNvPr id="11" name="Rectangle 10"/>
-          <p:cNvSpPr/>
-          <p:nvPr/>
-        </p:nvSpPr>
-        <p:spPr>
-          <a:xfrm>
-            <a:off x="35926000" y="2200000"/>
-            <a:ext cx="50000" cy="50000"/>
-          </a:xfrm>
-          <a:prstGeom prst="rect">
-            <a:avLst/>
-          </a:prstGeom>
-          <a:solidFill>
-            <a:srgbClr val="2E86AB"/>
-          </a:solidFill>
-          <a:ln>
-            <a:noFill/>
-          </a:ln>
-        </p:spPr>
-        <p:style>
-          <a:lnRef idx="1">
-            <a:schemeClr val="accent1"/>
-          </a:lnRef>
-          <a:fillRef idx="3">
-            <a:schemeClr val="accent1"/>
-          </a:fillRef>
-          <a:effectRef idx="2">
-            <a:schemeClr val="accent1"/>
-          </a:effectRef>
-          <a:fontRef idx="minor">
-            <a:schemeClr val="lt1"/>
-          </a:fontRef>
-        </p:style>
-        <p:txBody>
-          <a:bodyPr rtlCol="0" anchor="ctr"/>
-          <a:lstStyle/>
-          <a:p>
-            <a:pPr algn="ctr"/>
-          </a:p>
-        </p:txBody>
-      </p:sp>
-      <p:sp>
-        <p:nvSpPr>
-          <p:cNvPr id="12" name="Rectangle 11"/>
-          <p:cNvSpPr/>
-          <p:nvPr/>
-        </p:nvSpPr>
-        <p:spPr>
-          <a:xfrm>
-            <a:off x="35726000" y="2200000"/>
-            <a:ext cx="50000" cy="50000"/>
-          </a:xfrm>
-          <a:prstGeom prst="rect">
-            <a:avLst/>
-          </a:prstGeom>
-          <a:solidFill>
-            <a:srgbClr val="2E86AB"/>
-          </a:solidFill>
-          <a:ln>
-            <a:noFill/>
-          </a:ln>
-        </p:spPr>
-        <p:style>
-          <a:lnRef idx="1">
-            <a:schemeClr val="accent1"/>
-          </a:lnRef>
-          <a:fillRef idx="3">
-            <a:schemeClr val="accent1"/>
-          </a:fillRef>
-          <a:effectRef idx="2">
-            <a:schemeClr val="accent1"/>
-          </a:effectRef>
-          <a:fontRef idx="minor">
-            <a:schemeClr val="lt1"/>
-          </a:fontRef>
-        </p:style>
-        <p:txBody>
-          <a:bodyPr rtlCol="0" anchor="ctr"/>
-          <a:lstStyle/>
-          <a:p>
-            <a:pPr algn="ctr"/>
-          </a:p>
-        </p:txBody>
-      </p:sp>
-      <p:sp>
-        <p:nvSpPr>
-          <p:cNvPr id="13" name="Rectangle 12"/>
-          <p:cNvSpPr/>
-          <p:nvPr/>
-        </p:nvSpPr>
-        <p:spPr>
-          <a:xfrm>
-            <a:off x="35526000" y="2200000"/>
-            <a:ext cx="50000" cy="50000"/>
-          </a:xfrm>
-          <a:prstGeom prst="rect">
-            <a:avLst/>
-          </a:prstGeom>
-          <a:solidFill>
-            <a:srgbClr val="2E86AB"/>
-          </a:solidFill>
-          <a:ln>
-            <a:noFill/>
-          </a:ln>
-        </p:spPr>
-        <p:style>
-          <a:lnRef idx="1">
-            <a:schemeClr val="accent1"/>
-          </a:lnRef>
-          <a:fillRef idx="3">
-            <a:schemeClr val="accent1"/>
-          </a:fillRef>
-          <a:effectRef idx="2">
-            <a:schemeClr val="accent1"/>
-          </a:effectRef>
-          <a:fontRef idx="minor">
-            <a:schemeClr val="lt1"/>
-          </a:fontRef>
-        </p:style>
-        <p:txBody>
-          <a:bodyPr rtlCol="0" anchor="ctr"/>
-          <a:lstStyle/>
-          <a:p>
-            <a:pPr algn="ctr"/>
-          </a:p>
-        </p:txBody>
-      </p:sp>
-      <p:sp>
-        <p:nvSpPr>
-          <p:cNvPr id="14" name="Rectangle 13"/>
-          <p:cNvSpPr/>
-          <p:nvPr/>
-        </p:nvSpPr>
-        <p:spPr>
-          <a:xfrm>
-            <a:off x="9381500" y="2900000"/>
-            <a:ext cx="15000" cy="12800000"/>
-          </a:xfrm>
-          <a:prstGeom prst="rect">
-            <a:avLst/>
-          </a:prstGeom>
-          <a:solidFill>
-            <a:srgbClr val="DDDDDD"/>
-          </a:solidFill>
-          <a:ln>
-            <a:noFill/>
-          </a:ln>
-        </p:spPr>
-        <p:style>
-          <a:lnRef idx="1">
-            <a:schemeClr val="accent1"/>
-          </a:lnRef>
-          <a:fillRef idx="3">
-            <a:schemeClr val="accent1"/>
-          </a:fillRef>
-          <a:effectRef idx="2">
-            <a:schemeClr val="accent1"/>
-          </a:effectRef>
-          <a:fontRef idx="minor">
-            <a:schemeClr val="lt1"/>
-          </a:fontRef>
-        </p:style>
-        <p:txBody>
-          <a:bodyPr rtlCol="0" anchor="ctr"/>
-          <a:lstStyle/>
-          <a:p>
-            <a:pPr algn="ctr"/>
-          </a:p>
-        </p:txBody>
-      </p:sp>
-      <p:sp>
-        <p:nvSpPr>
           <p:cNvPr id="15" name="Rectangle 14"/>
           <p:cNvSpPr/>
           <p:nvPr/>
         </p:nvSpPr>
         <p:spPr>
           <a:xfrm>
-            <a:off x="18288000" y="2900000"/>
-            <a:ext cx="15000" cy="12800000"/>
-          </a:xfrm>
-          <a:prstGeom prst="rect">
-            <a:avLst/>
-          </a:prstGeom>
-          <a:solidFill>
-            <a:srgbClr val="DDDDDD"/>
-          </a:solidFill>
-          <a:ln>
-            <a:noFill/>
-          </a:ln>
-        </p:spPr>
-        <p:style>
-          <a:lnRef idx="1">
-            <a:schemeClr val="accent1"/>
-          </a:lnRef>
-          <a:fillRef idx="3">
-            <a:schemeClr val="accent1"/>
-          </a:fillRef>
-          <a:effectRef idx="2">
-            <a:schemeClr val="accent1"/>
-          </a:effectRef>
-          <a:fontRef idx="minor">
-            <a:schemeClr val="lt1"/>
-          </a:fontRef>
-        </p:style>
-        <p:txBody>
-          <a:bodyPr rtlCol="0" anchor="ctr"/>
-          <a:lstStyle/>
-          <a:p>
-            <a:pPr algn="ctr"/>
-          </a:p>
-        </p:txBody>
-      </p:sp>
-      <p:sp>
-        <p:nvSpPr>
-          <p:cNvPr id="16" name="Rectangle 15"/>
-          <p:cNvSpPr/>
-          <p:nvPr/>
-        </p:nvSpPr>
-        <p:spPr>
-          <a:xfrm>
-            <a:off x="27194500" y="2900000"/>
-            <a:ext cx="15000" cy="12800000"/>
-          </a:xfrm>
-          <a:prstGeom prst="rect">
-            <a:avLst/>
-          </a:prstGeom>
-          <a:solidFill>
-            <a:srgbClr val="DDDDDD"/>
-          </a:solidFill>
-          <a:ln>
-            <a:noFill/>
-          </a:ln>
-        </p:spPr>
-        <p:style>
-          <a:lnRef idx="1">
-            <a:schemeClr val="accent1"/>
-          </a:lnRef>
-          <a:fillRef idx="3">
-            <a:schemeClr val="accent1"/>
-          </a:fillRef>
-          <a:effectRef idx="2">
-            <a:schemeClr val="accent1"/>
-          </a:effectRef>
-          <a:fontRef idx="minor">
-            <a:schemeClr val="lt1"/>
-          </a:fontRef>
-        </p:style>
-        <p:txBody>
-          <a:bodyPr rtlCol="0" anchor="ctr"/>
-          <a:lstStyle/>
-          <a:p>
-            <a:pPr algn="ctr"/>
-          </a:p>
-        </p:txBody>
-      </p:sp>
-      <p:sp>
-        <p:nvSpPr>
-          <p:cNvPr id="17" name="Rectangle 16"/>
-          <p:cNvSpPr/>
-          <p:nvPr/>
-        </p:nvSpPr>
-        <p:spPr>
-          <a:xfrm>
-            <a:off x="700000" y="2900000"/>
-            <a:ext cx="8456500" cy="720000"/>
-          </a:xfrm>
-          <a:prstGeom prst="rect">
-            <a:avLst/>
-          </a:prstGeom>
-          <a:solidFill>
-            <a:srgbClr val="2E86AB"/>
-          </a:solidFill>
-          <a:ln>
-            <a:noFill/>
-          </a:ln>
-        </p:spPr>
-        <p:style>
-          <a:lnRef idx="1">
-            <a:schemeClr val="accent1"/>
-          </a:lnRef>
-          <a:fillRef idx="3">
-            <a:schemeClr val="accent1"/>
-          </a:fillRef>
-          <a:effectRef idx="2">
-            <a:schemeClr val="accent1"/>
-          </a:effectRef>
-          <a:fontRef idx="minor">
-            <a:schemeClr val="lt1"/>
-          </a:fontRef>
-        </p:style>
-        <p:txBody>
-          <a:bodyPr rtlCol="0" anchor="ctr"/>
-          <a:lstStyle/>
-          <a:p>
-            <a:pPr algn="ctr"/>
-          </a:p>
-        </p:txBody>
-      </p:sp>
-      <p:sp>
-        <p:nvSpPr>
-          <p:cNvPr id="18" name="Rectangle 17"/>
-          <p:cNvSpPr/>
-          <p:nvPr/>
-        </p:nvSpPr>
-        <p:spPr>
-          <a:xfrm>
-            <a:off x="700000" y="2900000"/>
+            <a:off x="700000" y="3150000"/>
             <a:ext cx="90000" cy="720000"/>
           </a:xfrm>
           <a:prstGeom prst="rect">
@@ -3837,13 +3757,13 @@
       </p:sp>
       <p:sp>
         <p:nvSpPr>
-          <p:cNvPr id="19" name="TextBox 18"/>
+          <p:cNvPr id="16" name="TextBox 15"/>
           <p:cNvSpPr txBox="1"/>
           <p:nvPr/>
         </p:nvSpPr>
         <p:spPr>
           <a:xfrm>
-            <a:off x="830000" y="2990000"/>
+            <a:off x="830000" y="3240000"/>
             <a:ext cx="400000" cy="540000"/>
           </a:xfrm>
           <a:prstGeom prst="rect">
@@ -3882,13 +3802,13 @@
       </p:sp>
       <p:sp>
         <p:nvSpPr>
-          <p:cNvPr id="20" name="TextBox 19"/>
+          <p:cNvPr id="17" name="TextBox 16"/>
           <p:cNvSpPr txBox="1"/>
           <p:nvPr/>
         </p:nvSpPr>
         <p:spPr>
           <a:xfrm>
-            <a:off x="1150000" y="3010000"/>
+            <a:off x="1150000" y="3260000"/>
             <a:ext cx="8106500" cy="500000"/>
           </a:xfrm>
           <a:prstGeom prst="rect">
@@ -3927,13 +3847,13 @@
       </p:sp>
       <p:sp>
         <p:nvSpPr>
-          <p:cNvPr id="21" name="Rectangle 20"/>
+          <p:cNvPr id="18" name="Rectangle 17"/>
           <p:cNvSpPr/>
           <p:nvPr/>
         </p:nvSpPr>
         <p:spPr>
           <a:xfrm>
-            <a:off x="700000" y="3570000"/>
+            <a:off x="700000" y="3820000"/>
             <a:ext cx="8456500" cy="50000"/>
           </a:xfrm>
           <a:prstGeom prst="rect">
@@ -3970,14 +3890,14 @@
       </p:sp>
       <p:sp>
         <p:nvSpPr>
-          <p:cNvPr id="22" name="Rounded Rectangle 21"/>
+          <p:cNvPr id="19" name="Rounded Rectangle 18"/>
           <p:cNvSpPr/>
           <p:nvPr/>
         </p:nvSpPr>
         <p:spPr>
           <a:xfrm>
-            <a:off x="700000" y="3620000"/>
-            <a:ext cx="8456500" cy="3650000"/>
+            <a:off x="700000" y="3870000"/>
+            <a:ext cx="8456500" cy="3550000"/>
           </a:xfrm>
           <a:prstGeom prst="roundRect">
             <a:avLst>
@@ -4017,14 +3937,14 @@
       </p:sp>
       <p:sp>
         <p:nvSpPr>
-          <p:cNvPr id="23" name="TextBox 22"/>
+          <p:cNvPr id="20" name="TextBox 19"/>
           <p:cNvSpPr txBox="1"/>
           <p:nvPr/>
         </p:nvSpPr>
         <p:spPr>
           <a:xfrm>
-            <a:off x="900000" y="3740000"/>
-            <a:ext cx="8056500" cy="3450000"/>
+            <a:off x="900000" y="3990000"/>
+            <a:ext cx="8056500" cy="3350000"/>
           </a:xfrm>
           <a:prstGeom prst="rect">
             <a:avLst/>
@@ -4230,13 +4150,13 @@
       </p:sp>
       <p:sp>
         <p:nvSpPr>
-          <p:cNvPr id="24" name="Rectangle 23"/>
+          <p:cNvPr id="21" name="Rectangle 20"/>
           <p:cNvSpPr/>
           <p:nvPr/>
         </p:nvSpPr>
         <p:spPr>
           <a:xfrm>
-            <a:off x="700000" y="7470000"/>
+            <a:off x="700000" y="7620000"/>
             <a:ext cx="8456500" cy="720000"/>
           </a:xfrm>
           <a:prstGeom prst="rect">
@@ -4273,13 +4193,13 @@
       </p:sp>
       <p:sp>
         <p:nvSpPr>
-          <p:cNvPr id="25" name="Rectangle 24"/>
+          <p:cNvPr id="22" name="Rectangle 21"/>
           <p:cNvSpPr/>
           <p:nvPr/>
         </p:nvSpPr>
         <p:spPr>
           <a:xfrm>
-            <a:off x="700000" y="7470000"/>
+            <a:off x="700000" y="7620000"/>
             <a:ext cx="90000" cy="720000"/>
           </a:xfrm>
           <a:prstGeom prst="rect">
@@ -4316,13 +4236,13 @@
       </p:sp>
       <p:sp>
         <p:nvSpPr>
-          <p:cNvPr id="26" name="TextBox 25"/>
+          <p:cNvPr id="23" name="TextBox 22"/>
           <p:cNvSpPr txBox="1"/>
           <p:nvPr/>
         </p:nvSpPr>
         <p:spPr>
           <a:xfrm>
-            <a:off x="830000" y="7560000"/>
+            <a:off x="830000" y="7710000"/>
             <a:ext cx="400000" cy="540000"/>
           </a:xfrm>
           <a:prstGeom prst="rect">
@@ -4361,13 +4281,13 @@
       </p:sp>
       <p:sp>
         <p:nvSpPr>
-          <p:cNvPr id="27" name="TextBox 26"/>
+          <p:cNvPr id="24" name="TextBox 23"/>
           <p:cNvSpPr txBox="1"/>
           <p:nvPr/>
         </p:nvSpPr>
         <p:spPr>
           <a:xfrm>
-            <a:off x="1150000" y="7580000"/>
+            <a:off x="1150000" y="7730000"/>
             <a:ext cx="8106500" cy="500000"/>
           </a:xfrm>
           <a:prstGeom prst="rect">
@@ -4406,13 +4326,13 @@
       </p:sp>
       <p:sp>
         <p:nvSpPr>
-          <p:cNvPr id="28" name="Rectangle 27"/>
+          <p:cNvPr id="25" name="Rectangle 24"/>
           <p:cNvSpPr/>
           <p:nvPr/>
         </p:nvSpPr>
         <p:spPr>
           <a:xfrm>
-            <a:off x="700000" y="8140000"/>
+            <a:off x="700000" y="8290000"/>
             <a:ext cx="8456500" cy="50000"/>
           </a:xfrm>
           <a:prstGeom prst="rect">
@@ -4449,14 +4369,14 @@
       </p:sp>
       <p:sp>
         <p:nvSpPr>
-          <p:cNvPr id="29" name="Rounded Rectangle 28"/>
+          <p:cNvPr id="26" name="Rounded Rectangle 25"/>
           <p:cNvSpPr/>
           <p:nvPr/>
         </p:nvSpPr>
         <p:spPr>
           <a:xfrm>
-            <a:off x="700000" y="8190000"/>
-            <a:ext cx="8456500" cy="3350000"/>
+            <a:off x="700000" y="8340000"/>
+            <a:ext cx="8456500" cy="3250000"/>
           </a:xfrm>
           <a:prstGeom prst="roundRect">
             <a:avLst>
@@ -4496,14 +4416,14 @@
       </p:sp>
       <p:sp>
         <p:nvSpPr>
-          <p:cNvPr id="30" name="TextBox 29"/>
+          <p:cNvPr id="27" name="TextBox 26"/>
           <p:cNvSpPr txBox="1"/>
           <p:nvPr/>
         </p:nvSpPr>
         <p:spPr>
           <a:xfrm>
-            <a:off x="900000" y="8310000"/>
-            <a:ext cx="8056500" cy="3150000"/>
+            <a:off x="900000" y="8460000"/>
+            <a:ext cx="8056500" cy="3050000"/>
           </a:xfrm>
           <a:prstGeom prst="rect">
             <a:avLst/>
@@ -4768,13 +4688,13 @@
       </p:sp>
       <p:sp>
         <p:nvSpPr>
-          <p:cNvPr id="31" name="Rectangle 30"/>
+          <p:cNvPr id="28" name="Rectangle 27"/>
           <p:cNvSpPr/>
           <p:nvPr/>
         </p:nvSpPr>
         <p:spPr>
           <a:xfrm>
-            <a:off x="700000" y="11740000"/>
+            <a:off x="700000" y="11790000"/>
             <a:ext cx="8456500" cy="720000"/>
           </a:xfrm>
           <a:prstGeom prst="rect">
@@ -4811,13 +4731,13 @@
       </p:sp>
       <p:sp>
         <p:nvSpPr>
-          <p:cNvPr id="32" name="Rectangle 31"/>
+          <p:cNvPr id="29" name="Rectangle 28"/>
           <p:cNvSpPr/>
           <p:nvPr/>
         </p:nvSpPr>
         <p:spPr>
           <a:xfrm>
-            <a:off x="700000" y="11740000"/>
+            <a:off x="700000" y="11790000"/>
             <a:ext cx="90000" cy="720000"/>
           </a:xfrm>
           <a:prstGeom prst="rect">
@@ -4854,13 +4774,13 @@
       </p:sp>
       <p:sp>
         <p:nvSpPr>
-          <p:cNvPr id="33" name="TextBox 32"/>
+          <p:cNvPr id="30" name="TextBox 29"/>
           <p:cNvSpPr txBox="1"/>
           <p:nvPr/>
         </p:nvSpPr>
         <p:spPr>
           <a:xfrm>
-            <a:off x="830000" y="11830000"/>
+            <a:off x="830000" y="11880000"/>
             <a:ext cx="400000" cy="540000"/>
           </a:xfrm>
           <a:prstGeom prst="rect">
@@ -4899,13 +4819,13 @@
       </p:sp>
       <p:sp>
         <p:nvSpPr>
-          <p:cNvPr id="34" name="TextBox 33"/>
+          <p:cNvPr id="31" name="TextBox 30"/>
           <p:cNvSpPr txBox="1"/>
           <p:nvPr/>
         </p:nvSpPr>
         <p:spPr>
           <a:xfrm>
-            <a:off x="1150000" y="11850000"/>
+            <a:off x="1150000" y="11900000"/>
             <a:ext cx="8106500" cy="500000"/>
           </a:xfrm>
           <a:prstGeom prst="rect">
@@ -4944,13 +4864,13 @@
       </p:sp>
       <p:sp>
         <p:nvSpPr>
-          <p:cNvPr id="35" name="Rectangle 34"/>
+          <p:cNvPr id="32" name="Rectangle 31"/>
           <p:cNvSpPr/>
           <p:nvPr/>
         </p:nvSpPr>
         <p:spPr>
           <a:xfrm>
-            <a:off x="700000" y="12410000"/>
+            <a:off x="700000" y="12460000"/>
             <a:ext cx="8456500" cy="50000"/>
           </a:xfrm>
           <a:prstGeom prst="rect">
@@ -4987,13 +4907,13 @@
       </p:sp>
       <p:sp>
         <p:nvSpPr>
-          <p:cNvPr id="36" name="Rounded Rectangle 35"/>
+          <p:cNvPr id="33" name="Rounded Rectangle 32"/>
           <p:cNvSpPr/>
           <p:nvPr/>
         </p:nvSpPr>
         <p:spPr>
           <a:xfrm>
-            <a:off x="700000" y="12460000"/>
+            <a:off x="700000" y="12510000"/>
             <a:ext cx="8456500" cy="3200000"/>
           </a:xfrm>
           <a:prstGeom prst="roundRect">
@@ -5034,13 +4954,13 @@
       </p:sp>
       <p:sp>
         <p:nvSpPr>
-          <p:cNvPr id="37" name="TextBox 36"/>
+          <p:cNvPr id="34" name="TextBox 33"/>
           <p:cNvSpPr txBox="1"/>
           <p:nvPr/>
         </p:nvSpPr>
         <p:spPr>
           <a:xfrm>
-            <a:off x="900000" y="12580000"/>
+            <a:off x="900000" y="12630000"/>
             <a:ext cx="8056500" cy="3000000"/>
           </a:xfrm>
           <a:prstGeom prst="rect">
@@ -5347,13 +5267,13 @@
       </p:sp>
       <p:sp>
         <p:nvSpPr>
-          <p:cNvPr id="38" name="Rectangle 37"/>
+          <p:cNvPr id="35" name="Rectangle 34"/>
           <p:cNvSpPr/>
           <p:nvPr/>
         </p:nvSpPr>
         <p:spPr>
           <a:xfrm>
-            <a:off x="9606500" y="2900000"/>
+            <a:off x="9606500" y="3150000"/>
             <a:ext cx="8456500" cy="720000"/>
           </a:xfrm>
           <a:prstGeom prst="rect">
@@ -5390,13 +5310,13 @@
       </p:sp>
       <p:sp>
         <p:nvSpPr>
-          <p:cNvPr id="39" name="Rectangle 38"/>
+          <p:cNvPr id="36" name="Rectangle 35"/>
           <p:cNvSpPr/>
           <p:nvPr/>
         </p:nvSpPr>
         <p:spPr>
           <a:xfrm>
-            <a:off x="9606500" y="2900000"/>
+            <a:off x="9606500" y="3150000"/>
             <a:ext cx="90000" cy="720000"/>
           </a:xfrm>
           <a:prstGeom prst="rect">
@@ -5433,13 +5353,13 @@
       </p:sp>
       <p:sp>
         <p:nvSpPr>
-          <p:cNvPr id="40" name="TextBox 39"/>
+          <p:cNvPr id="37" name="TextBox 36"/>
           <p:cNvSpPr txBox="1"/>
           <p:nvPr/>
         </p:nvSpPr>
         <p:spPr>
           <a:xfrm>
-            <a:off x="9736500" y="2990000"/>
+            <a:off x="9736500" y="3240000"/>
             <a:ext cx="400000" cy="540000"/>
           </a:xfrm>
           <a:prstGeom prst="rect">
@@ -5478,13 +5398,13 @@
       </p:sp>
       <p:sp>
         <p:nvSpPr>
-          <p:cNvPr id="41" name="TextBox 40"/>
+          <p:cNvPr id="38" name="TextBox 37"/>
           <p:cNvSpPr txBox="1"/>
           <p:nvPr/>
         </p:nvSpPr>
         <p:spPr>
           <a:xfrm>
-            <a:off x="10056500" y="3010000"/>
+            <a:off x="10056500" y="3260000"/>
             <a:ext cx="8106500" cy="500000"/>
           </a:xfrm>
           <a:prstGeom prst="rect">
@@ -5523,13 +5443,13 @@
       </p:sp>
       <p:sp>
         <p:nvSpPr>
-          <p:cNvPr id="42" name="Rectangle 41"/>
+          <p:cNvPr id="39" name="Rectangle 38"/>
           <p:cNvSpPr/>
           <p:nvPr/>
         </p:nvSpPr>
         <p:spPr>
           <a:xfrm>
-            <a:off x="9606500" y="3570000"/>
+            <a:off x="9606500" y="3820000"/>
             <a:ext cx="8456500" cy="50000"/>
           </a:xfrm>
           <a:prstGeom prst="rect">
@@ -5566,14 +5486,14 @@
       </p:sp>
       <p:sp>
         <p:nvSpPr>
-          <p:cNvPr id="43" name="Rounded Rectangle 42"/>
+          <p:cNvPr id="40" name="Rounded Rectangle 39"/>
           <p:cNvSpPr/>
           <p:nvPr/>
         </p:nvSpPr>
         <p:spPr>
           <a:xfrm>
-            <a:off x="9606500" y="3620000"/>
-            <a:ext cx="8456500" cy="5400000"/>
+            <a:off x="9606500" y="3870000"/>
+            <a:ext cx="8456500" cy="5600000"/>
           </a:xfrm>
           <a:prstGeom prst="roundRect">
             <a:avLst>
@@ -5613,14 +5533,14 @@
       </p:sp>
       <p:sp>
         <p:nvSpPr>
-          <p:cNvPr id="44" name="TextBox 43"/>
+          <p:cNvPr id="41" name="TextBox 40"/>
           <p:cNvSpPr txBox="1"/>
           <p:nvPr/>
         </p:nvSpPr>
         <p:spPr>
           <a:xfrm>
-            <a:off x="9806500" y="3740000"/>
-            <a:ext cx="8056500" cy="5200000"/>
+            <a:off x="9806500" y="3990000"/>
+            <a:ext cx="8056500" cy="5400000"/>
           </a:xfrm>
           <a:prstGeom prst="rect">
             <a:avLst/>
@@ -6122,13 +6042,13 @@
       </p:sp>
       <p:sp>
         <p:nvSpPr>
-          <p:cNvPr id="45" name="Rectangle 44"/>
+          <p:cNvPr id="42" name="Rectangle 41"/>
           <p:cNvSpPr/>
           <p:nvPr/>
         </p:nvSpPr>
         <p:spPr>
           <a:xfrm>
-            <a:off x="9606500" y="9220000"/>
+            <a:off x="9606500" y="9670000"/>
             <a:ext cx="8456500" cy="720000"/>
           </a:xfrm>
           <a:prstGeom prst="rect">
@@ -6165,13 +6085,13 @@
       </p:sp>
       <p:sp>
         <p:nvSpPr>
-          <p:cNvPr id="46" name="Rectangle 45"/>
+          <p:cNvPr id="43" name="Rectangle 42"/>
           <p:cNvSpPr/>
           <p:nvPr/>
         </p:nvSpPr>
         <p:spPr>
           <a:xfrm>
-            <a:off x="9606500" y="9220000"/>
+            <a:off x="9606500" y="9670000"/>
             <a:ext cx="90000" cy="720000"/>
           </a:xfrm>
           <a:prstGeom prst="rect">
@@ -6208,13 +6128,13 @@
       </p:sp>
       <p:sp>
         <p:nvSpPr>
-          <p:cNvPr id="47" name="TextBox 46"/>
+          <p:cNvPr id="44" name="TextBox 43"/>
           <p:cNvSpPr txBox="1"/>
           <p:nvPr/>
         </p:nvSpPr>
         <p:spPr>
           <a:xfrm>
-            <a:off x="9856500" y="9330000"/>
+            <a:off x="9856500" y="9780000"/>
             <a:ext cx="8106500" cy="500000"/>
           </a:xfrm>
           <a:prstGeom prst="rect">
@@ -6253,13 +6173,13 @@
       </p:sp>
       <p:sp>
         <p:nvSpPr>
-          <p:cNvPr id="48" name="Rectangle 47"/>
+          <p:cNvPr id="45" name="Rectangle 44"/>
           <p:cNvSpPr/>
           <p:nvPr/>
         </p:nvSpPr>
         <p:spPr>
           <a:xfrm>
-            <a:off x="9606500" y="9890000"/>
+            <a:off x="9606500" y="10340000"/>
             <a:ext cx="8456500" cy="50000"/>
           </a:xfrm>
           <a:prstGeom prst="rect">
@@ -6296,14 +6216,14 @@
       </p:sp>
       <p:sp>
         <p:nvSpPr>
-          <p:cNvPr id="49" name="Rounded Rectangle 48"/>
+          <p:cNvPr id="46" name="Rounded Rectangle 45"/>
           <p:cNvSpPr/>
           <p:nvPr/>
         </p:nvSpPr>
         <p:spPr>
           <a:xfrm>
-            <a:off x="9606500" y="9940000"/>
-            <a:ext cx="8456500" cy="4600000"/>
+            <a:off x="9606500" y="10390000"/>
+            <a:ext cx="8456500" cy="4800000"/>
           </a:xfrm>
           <a:prstGeom prst="roundRect">
             <a:avLst>
@@ -6343,7 +6263,7 @@
       </p:sp>
       <p:pic>
         <p:nvPicPr>
-          <p:cNvPr id="50" name="Picture 49" descr="feature_groups_final.png"/>
+          <p:cNvPr id="47" name="Picture 46" descr="feature_groups_final.png"/>
           <p:cNvPicPr>
             <a:picLocks noChangeAspect="1"/>
           </p:cNvPicPr>
@@ -6357,8 +6277,8 @@
         </p:blipFill>
         <p:spPr>
           <a:xfrm>
-            <a:off x="9756500" y="10190000"/>
-            <a:ext cx="8156500" cy="4100000"/>
+            <a:off x="9756500" y="10640000"/>
+            <a:ext cx="8156500" cy="4300000"/>
           </a:xfrm>
           <a:prstGeom prst="rect">
             <a:avLst/>
@@ -6367,13 +6287,13 @@
       </p:pic>
       <p:sp>
         <p:nvSpPr>
-          <p:cNvPr id="51" name="Rectangle 50"/>
+          <p:cNvPr id="48" name="Rectangle 47"/>
           <p:cNvSpPr/>
           <p:nvPr/>
         </p:nvSpPr>
         <p:spPr>
           <a:xfrm>
-            <a:off x="18513000" y="2900000"/>
+            <a:off x="18513000" y="3150000"/>
             <a:ext cx="8456500" cy="720000"/>
           </a:xfrm>
           <a:prstGeom prst="rect">
@@ -6410,13 +6330,13 @@
       </p:sp>
       <p:sp>
         <p:nvSpPr>
-          <p:cNvPr id="52" name="Rectangle 51"/>
+          <p:cNvPr id="49" name="Rectangle 48"/>
           <p:cNvSpPr/>
           <p:nvPr/>
         </p:nvSpPr>
         <p:spPr>
           <a:xfrm>
-            <a:off x="18513000" y="2900000"/>
+            <a:off x="18513000" y="3150000"/>
             <a:ext cx="90000" cy="720000"/>
           </a:xfrm>
           <a:prstGeom prst="rect">
@@ -6453,13 +6373,13 @@
       </p:sp>
       <p:sp>
         <p:nvSpPr>
-          <p:cNvPr id="53" name="TextBox 52"/>
+          <p:cNvPr id="50" name="TextBox 49"/>
           <p:cNvSpPr txBox="1"/>
           <p:nvPr/>
         </p:nvSpPr>
         <p:spPr>
           <a:xfrm>
-            <a:off x="18643000" y="2990000"/>
+            <a:off x="18643000" y="3240000"/>
             <a:ext cx="400000" cy="540000"/>
           </a:xfrm>
           <a:prstGeom prst="rect">
@@ -6498,13 +6418,13 @@
       </p:sp>
       <p:sp>
         <p:nvSpPr>
-          <p:cNvPr id="54" name="TextBox 53"/>
+          <p:cNvPr id="51" name="TextBox 50"/>
           <p:cNvSpPr txBox="1"/>
           <p:nvPr/>
         </p:nvSpPr>
         <p:spPr>
           <a:xfrm>
-            <a:off x="18963000" y="3010000"/>
+            <a:off x="18963000" y="3260000"/>
             <a:ext cx="8106500" cy="500000"/>
           </a:xfrm>
           <a:prstGeom prst="rect">
@@ -6543,13 +6463,13 @@
       </p:sp>
       <p:sp>
         <p:nvSpPr>
-          <p:cNvPr id="55" name="Rectangle 54"/>
+          <p:cNvPr id="52" name="Rectangle 51"/>
           <p:cNvSpPr/>
           <p:nvPr/>
         </p:nvSpPr>
         <p:spPr>
           <a:xfrm>
-            <a:off x="18513000" y="3570000"/>
+            <a:off x="18513000" y="3820000"/>
             <a:ext cx="8456500" cy="50000"/>
           </a:xfrm>
           <a:prstGeom prst="rect">
@@ -6586,13 +6506,13 @@
       </p:sp>
       <p:sp>
         <p:nvSpPr>
-          <p:cNvPr id="56" name="Rounded Rectangle 55"/>
+          <p:cNvPr id="53" name="Rounded Rectangle 52"/>
           <p:cNvSpPr/>
           <p:nvPr/>
         </p:nvSpPr>
         <p:spPr>
           <a:xfrm>
-            <a:off x="18513000" y="3620000"/>
+            <a:off x="18513000" y="3870000"/>
             <a:ext cx="8456500" cy="4600000"/>
           </a:xfrm>
           <a:prstGeom prst="roundRect">
@@ -6633,13 +6553,13 @@
       </p:sp>
       <p:sp>
         <p:nvSpPr>
-          <p:cNvPr id="57" name="TextBox 56"/>
+          <p:cNvPr id="54" name="TextBox 53"/>
           <p:cNvSpPr txBox="1"/>
           <p:nvPr/>
         </p:nvSpPr>
         <p:spPr>
           <a:xfrm>
-            <a:off x="18713000" y="3740000"/>
+            <a:off x="18713000" y="3990000"/>
             <a:ext cx="8056500" cy="4400000"/>
           </a:xfrm>
           <a:prstGeom prst="rect">
@@ -7031,13 +6951,13 @@
       </p:sp>
       <p:sp>
         <p:nvSpPr>
-          <p:cNvPr id="58" name="Rectangle 57"/>
+          <p:cNvPr id="55" name="Rectangle 54"/>
           <p:cNvSpPr/>
           <p:nvPr/>
         </p:nvSpPr>
         <p:spPr>
           <a:xfrm>
-            <a:off x="18513000" y="8420000"/>
+            <a:off x="18513000" y="8670000"/>
             <a:ext cx="8456500" cy="720000"/>
           </a:xfrm>
           <a:prstGeom prst="rect">
@@ -7074,13 +6994,13 @@
       </p:sp>
       <p:sp>
         <p:nvSpPr>
-          <p:cNvPr id="59" name="Rectangle 58"/>
+          <p:cNvPr id="56" name="Rectangle 55"/>
           <p:cNvSpPr/>
           <p:nvPr/>
         </p:nvSpPr>
         <p:spPr>
           <a:xfrm>
-            <a:off x="18513000" y="8420000"/>
+            <a:off x="18513000" y="8670000"/>
             <a:ext cx="90000" cy="720000"/>
           </a:xfrm>
           <a:prstGeom prst="rect">
@@ -7117,13 +7037,13 @@
       </p:sp>
       <p:sp>
         <p:nvSpPr>
-          <p:cNvPr id="60" name="TextBox 59"/>
+          <p:cNvPr id="57" name="TextBox 56"/>
           <p:cNvSpPr txBox="1"/>
           <p:nvPr/>
         </p:nvSpPr>
         <p:spPr>
           <a:xfrm>
-            <a:off x="18763000" y="8530000"/>
+            <a:off x="18763000" y="8780000"/>
             <a:ext cx="8106500" cy="500000"/>
           </a:xfrm>
           <a:prstGeom prst="rect">
@@ -7162,13 +7082,13 @@
       </p:sp>
       <p:sp>
         <p:nvSpPr>
-          <p:cNvPr id="61" name="Rectangle 60"/>
+          <p:cNvPr id="58" name="Rectangle 57"/>
           <p:cNvSpPr/>
           <p:nvPr/>
         </p:nvSpPr>
         <p:spPr>
           <a:xfrm>
-            <a:off x="18513000" y="9090000"/>
+            <a:off x="18513000" y="9340000"/>
             <a:ext cx="8456500" cy="50000"/>
           </a:xfrm>
           <a:prstGeom prst="rect">
@@ -7205,13 +7125,13 @@
       </p:sp>
       <p:sp>
         <p:nvSpPr>
-          <p:cNvPr id="62" name="Rounded Rectangle 61"/>
+          <p:cNvPr id="59" name="Rounded Rectangle 58"/>
           <p:cNvSpPr/>
           <p:nvPr/>
         </p:nvSpPr>
         <p:spPr>
           <a:xfrm>
-            <a:off x="18513000" y="9140000"/>
+            <a:off x="18513000" y="9390000"/>
             <a:ext cx="8456500" cy="5400000"/>
           </a:xfrm>
           <a:prstGeom prst="roundRect">
@@ -7252,7 +7172,7 @@
       </p:sp>
       <p:pic>
         <p:nvPicPr>
-          <p:cNvPr id="63" name="Picture 62" descr="arch_diagram_final.png"/>
+          <p:cNvPr id="60" name="Picture 59" descr="arch_diagram_final.png"/>
           <p:cNvPicPr>
             <a:picLocks noChangeAspect="1"/>
           </p:cNvPicPr>
@@ -7266,7 +7186,7 @@
         </p:blipFill>
         <p:spPr>
           <a:xfrm>
-            <a:off x="18633000" y="9390000"/>
+            <a:off x="18633000" y="9640000"/>
             <a:ext cx="8216500" cy="4900000"/>
           </a:xfrm>
           <a:prstGeom prst="rect">
@@ -7276,13 +7196,13 @@
       </p:pic>
       <p:sp>
         <p:nvSpPr>
-          <p:cNvPr id="64" name="Rectangle 63"/>
+          <p:cNvPr id="61" name="Rectangle 60"/>
           <p:cNvSpPr/>
           <p:nvPr/>
         </p:nvSpPr>
         <p:spPr>
           <a:xfrm>
-            <a:off x="27419500" y="2900000"/>
+            <a:off x="27419500" y="3150000"/>
             <a:ext cx="8456500" cy="720000"/>
           </a:xfrm>
           <a:prstGeom prst="rect">
@@ -7319,13 +7239,13 @@
       </p:sp>
       <p:sp>
         <p:nvSpPr>
-          <p:cNvPr id="65" name="Rectangle 64"/>
+          <p:cNvPr id="62" name="Rectangle 61"/>
           <p:cNvSpPr/>
           <p:nvPr/>
         </p:nvSpPr>
         <p:spPr>
           <a:xfrm>
-            <a:off x="27419500" y="2900000"/>
+            <a:off x="27419500" y="3150000"/>
             <a:ext cx="90000" cy="720000"/>
           </a:xfrm>
           <a:prstGeom prst="rect">
@@ -7362,13 +7282,13 @@
       </p:sp>
       <p:sp>
         <p:nvSpPr>
-          <p:cNvPr id="66" name="TextBox 65"/>
+          <p:cNvPr id="63" name="TextBox 62"/>
           <p:cNvSpPr txBox="1"/>
           <p:nvPr/>
         </p:nvSpPr>
         <p:spPr>
           <a:xfrm>
-            <a:off x="27549500" y="2990000"/>
+            <a:off x="27549500" y="3240000"/>
             <a:ext cx="400000" cy="540000"/>
           </a:xfrm>
           <a:prstGeom prst="rect">
@@ -7407,13 +7327,13 @@
       </p:sp>
       <p:sp>
         <p:nvSpPr>
-          <p:cNvPr id="67" name="TextBox 66"/>
+          <p:cNvPr id="64" name="TextBox 63"/>
           <p:cNvSpPr txBox="1"/>
           <p:nvPr/>
         </p:nvSpPr>
         <p:spPr>
           <a:xfrm>
-            <a:off x="27869500" y="3010000"/>
+            <a:off x="27869500" y="3260000"/>
             <a:ext cx="8106500" cy="500000"/>
           </a:xfrm>
           <a:prstGeom prst="rect">
@@ -7452,13 +7372,13 @@
       </p:sp>
       <p:sp>
         <p:nvSpPr>
-          <p:cNvPr id="68" name="Rectangle 67"/>
+          <p:cNvPr id="65" name="Rectangle 64"/>
           <p:cNvSpPr/>
           <p:nvPr/>
         </p:nvSpPr>
         <p:spPr>
           <a:xfrm>
-            <a:off x="27419500" y="3570000"/>
+            <a:off x="27419500" y="3820000"/>
             <a:ext cx="8456500" cy="50000"/>
           </a:xfrm>
           <a:prstGeom prst="rect">
@@ -7495,14 +7415,14 @@
       </p:sp>
       <p:sp>
         <p:nvSpPr>
-          <p:cNvPr id="69" name="Rounded Rectangle 68"/>
+          <p:cNvPr id="66" name="Rounded Rectangle 65"/>
           <p:cNvSpPr/>
           <p:nvPr/>
         </p:nvSpPr>
         <p:spPr>
           <a:xfrm>
-            <a:off x="27419500" y="3620000"/>
-            <a:ext cx="8456500" cy="3600000"/>
+            <a:off x="27419500" y="3870000"/>
+            <a:ext cx="8456500" cy="3400000"/>
           </a:xfrm>
           <a:prstGeom prst="roundRect">
             <a:avLst>
@@ -7542,14 +7462,14 @@
       </p:sp>
       <p:sp>
         <p:nvSpPr>
-          <p:cNvPr id="70" name="TextBox 69"/>
+          <p:cNvPr id="67" name="TextBox 66"/>
           <p:cNvSpPr txBox="1"/>
           <p:nvPr/>
         </p:nvSpPr>
         <p:spPr>
           <a:xfrm>
-            <a:off x="27619500" y="3740000"/>
-            <a:ext cx="8056500" cy="3400000"/>
+            <a:off x="27619500" y="3990000"/>
+            <a:ext cx="8056500" cy="3200000"/>
           </a:xfrm>
           <a:prstGeom prst="rect">
             <a:avLst/>
@@ -7907,13 +7827,13 @@
       </p:sp>
       <p:sp>
         <p:nvSpPr>
-          <p:cNvPr id="71" name="Rectangle 70"/>
+          <p:cNvPr id="68" name="Rectangle 67"/>
           <p:cNvSpPr/>
           <p:nvPr/>
         </p:nvSpPr>
         <p:spPr>
           <a:xfrm>
-            <a:off x="27419500" y="7400000"/>
+            <a:off x="27419500" y="7450000"/>
             <a:ext cx="8456500" cy="720000"/>
           </a:xfrm>
           <a:prstGeom prst="rect">
@@ -7950,13 +7870,13 @@
       </p:sp>
       <p:sp>
         <p:nvSpPr>
-          <p:cNvPr id="72" name="Rectangle 71"/>
+          <p:cNvPr id="69" name="Rectangle 68"/>
           <p:cNvSpPr/>
           <p:nvPr/>
         </p:nvSpPr>
         <p:spPr>
           <a:xfrm>
-            <a:off x="27419500" y="7400000"/>
+            <a:off x="27419500" y="7450000"/>
             <a:ext cx="90000" cy="720000"/>
           </a:xfrm>
           <a:prstGeom prst="rect">
@@ -7993,13 +7913,13 @@
       </p:sp>
       <p:sp>
         <p:nvSpPr>
-          <p:cNvPr id="73" name="TextBox 72"/>
+          <p:cNvPr id="70" name="TextBox 69"/>
           <p:cNvSpPr txBox="1"/>
           <p:nvPr/>
         </p:nvSpPr>
         <p:spPr>
           <a:xfrm>
-            <a:off x="27669500" y="7510000"/>
+            <a:off x="27669500" y="7560000"/>
             <a:ext cx="8106500" cy="500000"/>
           </a:xfrm>
           <a:prstGeom prst="rect">
@@ -8038,13 +7958,13 @@
       </p:sp>
       <p:sp>
         <p:nvSpPr>
-          <p:cNvPr id="74" name="Rectangle 73"/>
+          <p:cNvPr id="71" name="Rectangle 70"/>
           <p:cNvSpPr/>
           <p:nvPr/>
         </p:nvSpPr>
         <p:spPr>
           <a:xfrm>
-            <a:off x="27419500" y="8070000"/>
+            <a:off x="27419500" y="8120000"/>
             <a:ext cx="8456500" cy="50000"/>
           </a:xfrm>
           <a:prstGeom prst="rect">
@@ -8081,13 +8001,13 @@
       </p:sp>
       <p:sp>
         <p:nvSpPr>
-          <p:cNvPr id="75" name="Rounded Rectangle 74"/>
+          <p:cNvPr id="72" name="Rounded Rectangle 71"/>
           <p:cNvSpPr/>
           <p:nvPr/>
         </p:nvSpPr>
         <p:spPr>
           <a:xfrm>
-            <a:off x="27419500" y="8120000"/>
+            <a:off x="27419500" y="8170000"/>
             <a:ext cx="8456500" cy="3500000"/>
           </a:xfrm>
           <a:prstGeom prst="roundRect">
@@ -8128,7 +8048,7 @@
       </p:sp>
       <p:pic>
         <p:nvPicPr>
-          <p:cNvPr id="76" name="Picture 75" descr="f1_chart_final.png"/>
+          <p:cNvPr id="73" name="Picture 72" descr="f1_chart_final.png"/>
           <p:cNvPicPr>
             <a:picLocks noChangeAspect="1"/>
           </p:cNvPicPr>
@@ -8142,8 +8062,8 @@
         </p:blipFill>
         <p:spPr>
           <a:xfrm>
-            <a:off x="27539500" y="8300000"/>
-            <a:ext cx="8216500" cy="3150000"/>
+            <a:off x="27539500" y="8350000"/>
+            <a:ext cx="8216500" cy="3100000"/>
           </a:xfrm>
           <a:prstGeom prst="rect">
             <a:avLst/>
@@ -8152,13 +8072,13 @@
       </p:pic>
       <p:sp>
         <p:nvSpPr>
-          <p:cNvPr id="77" name="Rectangle 76"/>
+          <p:cNvPr id="74" name="Rectangle 73"/>
           <p:cNvSpPr/>
           <p:nvPr/>
         </p:nvSpPr>
         <p:spPr>
           <a:xfrm>
-            <a:off x="27419500" y="11800000"/>
+            <a:off x="27419500" y="11850000"/>
             <a:ext cx="8456500" cy="720000"/>
           </a:xfrm>
           <a:prstGeom prst="rect">
@@ -8195,13 +8115,13 @@
       </p:sp>
       <p:sp>
         <p:nvSpPr>
-          <p:cNvPr id="78" name="Rectangle 77"/>
+          <p:cNvPr id="75" name="Rectangle 74"/>
           <p:cNvSpPr/>
           <p:nvPr/>
         </p:nvSpPr>
         <p:spPr>
           <a:xfrm>
-            <a:off x="27419500" y="11800000"/>
+            <a:off x="27419500" y="11850000"/>
             <a:ext cx="90000" cy="720000"/>
           </a:xfrm>
           <a:prstGeom prst="rect">
@@ -8238,13 +8158,13 @@
       </p:sp>
       <p:sp>
         <p:nvSpPr>
-          <p:cNvPr id="79" name="TextBox 78"/>
+          <p:cNvPr id="76" name="TextBox 75"/>
           <p:cNvSpPr txBox="1"/>
           <p:nvPr/>
         </p:nvSpPr>
         <p:spPr>
           <a:xfrm>
-            <a:off x="27669500" y="11910000"/>
+            <a:off x="27669500" y="11960000"/>
             <a:ext cx="8106500" cy="500000"/>
           </a:xfrm>
           <a:prstGeom prst="rect">
@@ -8283,13 +8203,13 @@
       </p:sp>
       <p:sp>
         <p:nvSpPr>
-          <p:cNvPr id="80" name="Rectangle 79"/>
+          <p:cNvPr id="77" name="Rectangle 76"/>
           <p:cNvSpPr/>
           <p:nvPr/>
         </p:nvSpPr>
         <p:spPr>
           <a:xfrm>
-            <a:off x="27419500" y="12470000"/>
+            <a:off x="27419500" y="12520000"/>
             <a:ext cx="8456500" cy="50000"/>
           </a:xfrm>
           <a:prstGeom prst="rect">
@@ -8326,14 +8246,14 @@
       </p:sp>
       <p:sp>
         <p:nvSpPr>
-          <p:cNvPr id="81" name="Rounded Rectangle 80"/>
+          <p:cNvPr id="78" name="Rounded Rectangle 77"/>
           <p:cNvSpPr/>
           <p:nvPr/>
         </p:nvSpPr>
         <p:spPr>
           <a:xfrm>
-            <a:off x="27419500" y="12520000"/>
-            <a:ext cx="8456500" cy="2800000"/>
+            <a:off x="27419500" y="12570000"/>
+            <a:ext cx="8456500" cy="2900000"/>
           </a:xfrm>
           <a:prstGeom prst="roundRect">
             <a:avLst>
@@ -8373,7 +8293,7 @@
       </p:sp>
       <p:pic>
         <p:nvPicPr>
-          <p:cNvPr id="82" name="Picture 81" descr="cm_final.png"/>
+          <p:cNvPr id="79" name="Picture 78" descr="cm_final.png"/>
           <p:cNvPicPr>
             <a:picLocks noChangeAspect="1"/>
           </p:cNvPicPr>
@@ -8387,8 +8307,8 @@
         </p:blipFill>
         <p:spPr>
           <a:xfrm>
-            <a:off x="27479500" y="12670000"/>
-            <a:ext cx="8336500" cy="2500000"/>
+            <a:off x="27479500" y="12720000"/>
+            <a:ext cx="8336500" cy="2600000"/>
           </a:xfrm>
           <a:prstGeom prst="rect">
             <a:avLst/>
@@ -8397,7 +8317,7 @@
       </p:pic>
       <p:sp>
         <p:nvSpPr>
-          <p:cNvPr id="83" name="Rectangle 82"/>
+          <p:cNvPr id="80" name="Rectangle 79"/>
           <p:cNvSpPr/>
           <p:nvPr/>
         </p:nvSpPr>
@@ -8440,7 +8360,7 @@
       </p:sp>
       <p:sp>
         <p:nvSpPr>
-          <p:cNvPr id="84" name="Rectangle 83"/>
+          <p:cNvPr id="81" name="Rectangle 80"/>
           <p:cNvSpPr/>
           <p:nvPr/>
         </p:nvSpPr>
@@ -8483,7 +8403,7 @@
       </p:sp>
       <p:sp>
         <p:nvSpPr>
-          <p:cNvPr id="85" name="TextBox 84"/>
+          <p:cNvPr id="82" name="TextBox 81"/>
           <p:cNvSpPr txBox="1"/>
           <p:nvPr/>
         </p:nvSpPr>
@@ -8528,7 +8448,7 @@
       </p:sp>
       <p:sp>
         <p:nvSpPr>
-          <p:cNvPr id="86" name="Rectangle 85"/>
+          <p:cNvPr id="83" name="Rectangle 82"/>
           <p:cNvSpPr/>
           <p:nvPr/>
         </p:nvSpPr>
@@ -8571,7 +8491,7 @@
       </p:sp>
       <p:sp>
         <p:nvSpPr>
-          <p:cNvPr id="87" name="Rounded Rectangle 86"/>
+          <p:cNvPr id="84" name="Rounded Rectangle 83"/>
           <p:cNvSpPr/>
           <p:nvPr/>
         </p:nvSpPr>
@@ -8618,7 +8538,7 @@
       </p:sp>
       <p:sp>
         <p:nvSpPr>
-          <p:cNvPr id="88" name="TextBox 87"/>
+          <p:cNvPr id="85" name="TextBox 84"/>
           <p:cNvSpPr txBox="1"/>
           <p:nvPr/>
         </p:nvSpPr>
@@ -8837,7 +8757,7 @@
       </p:sp>
       <p:sp>
         <p:nvSpPr>
-          <p:cNvPr id="89" name="Rectangle 88"/>
+          <p:cNvPr id="86" name="Rectangle 85"/>
           <p:cNvSpPr/>
           <p:nvPr/>
         </p:nvSpPr>
@@ -8880,7 +8800,7 @@
       </p:sp>
       <p:sp>
         <p:nvSpPr>
-          <p:cNvPr id="90" name="Rectangle 89"/>
+          <p:cNvPr id="87" name="Rectangle 86"/>
           <p:cNvSpPr/>
           <p:nvPr/>
         </p:nvSpPr>
@@ -8923,7 +8843,7 @@
       </p:sp>
       <p:sp>
         <p:nvSpPr>
-          <p:cNvPr id="91" name="TextBox 90"/>
+          <p:cNvPr id="88" name="TextBox 87"/>
           <p:cNvSpPr txBox="1"/>
           <p:nvPr/>
         </p:nvSpPr>
@@ -8968,7 +8888,7 @@
       </p:sp>
       <p:sp>
         <p:nvSpPr>
-          <p:cNvPr id="92" name="Rectangle 91"/>
+          <p:cNvPr id="89" name="Rectangle 88"/>
           <p:cNvSpPr/>
           <p:nvPr/>
         </p:nvSpPr>
@@ -9011,7 +8931,7 @@
       </p:sp>
       <p:sp>
         <p:nvSpPr>
-          <p:cNvPr id="93" name="Rounded Rectangle 92"/>
+          <p:cNvPr id="90" name="Rounded Rectangle 89"/>
           <p:cNvSpPr/>
           <p:nvPr/>
         </p:nvSpPr>
@@ -9058,7 +8978,7 @@
       </p:sp>
       <p:sp>
         <p:nvSpPr>
-          <p:cNvPr id="94" name="TextBox 93"/>
+          <p:cNvPr id="91" name="TextBox 90"/>
           <p:cNvSpPr txBox="1"/>
           <p:nvPr/>
         </p:nvSpPr>
@@ -9353,7 +9273,7 @@
       </p:sp>
       <p:sp>
         <p:nvSpPr>
-          <p:cNvPr id="95" name="Rectangle 94"/>
+          <p:cNvPr id="92" name="Rectangle 91"/>
           <p:cNvSpPr/>
           <p:nvPr/>
         </p:nvSpPr>
@@ -9396,7 +9316,7 @@
       </p:sp>
       <p:sp>
         <p:nvSpPr>
-          <p:cNvPr id="96" name="Rectangle 95"/>
+          <p:cNvPr id="93" name="Rectangle 92"/>
           <p:cNvSpPr/>
           <p:nvPr/>
         </p:nvSpPr>
@@ -9439,7 +9359,7 @@
       </p:sp>
       <p:sp>
         <p:nvSpPr>
-          <p:cNvPr id="97" name="TextBox 96"/>
+          <p:cNvPr id="94" name="TextBox 93"/>
           <p:cNvSpPr txBox="1"/>
           <p:nvPr/>
         </p:nvSpPr>

</xml_diff>

<commit_message>
Poster iteration 5: Add MCC and accuracy to results table
</commit_message>
<xml_diff>
--- a/poster/poster_final.pptx
+++ b/poster/poster_final.pptx
@@ -7422,7 +7422,7 @@
         <p:spPr>
           <a:xfrm>
             <a:off x="27419500" y="3870000"/>
-            <a:ext cx="8456500" cy="3400000"/>
+            <a:ext cx="8456500" cy="3600000"/>
           </a:xfrm>
           <a:prstGeom prst="roundRect">
             <a:avLst>
@@ -7469,7 +7469,7 @@
         <p:spPr>
           <a:xfrm>
             <a:off x="27619500" y="3990000"/>
-            <a:ext cx="8056500" cy="3200000"/>
+            <a:ext cx="8056500" cy="3400000"/>
           </a:xfrm>
           <a:prstGeom prst="rect">
             <a:avLst/>
@@ -7712,26 +7712,97 @@
                 <a:spcPts val="0"/>
               </a:spcBef>
               <a:spcAft>
+                <a:spcPts val="100"/>
+              </a:spcAft>
+            </a:pPr>
+            <a:r>
+              <a:rPr sz="2200" b="1">
+                <a:solidFill>
+                  <a:srgbClr val="27AE60"/>
+                </a:solidFill>
+                <a:latin typeface="Calibri"/>
+              </a:rPr>
+              <a:t>★ Sol 1 (Cat A)   </a:t>
+            </a:r>
+            <a:r>
+              <a:rPr sz="2200" b="1">
+                <a:solidFill>
+                  <a:srgbClr val="27AE60"/>
+                </a:solidFill>
+                <a:latin typeface="Calibri"/>
+              </a:rPr>
+              <a:t>0.7340</a:t>
+            </a:r>
+            <a:r>
+              <a:rPr sz="2200" b="0">
+                <a:solidFill>
+                  <a:srgbClr val="2D2D2D"/>
+                </a:solidFill>
+                <a:latin typeface="Calibri"/>
+              </a:rPr>
+              <a:t>  </a:t>
+            </a:r>
+            <a:r>
+              <a:rPr sz="2200" b="1">
+                <a:solidFill>
+                  <a:srgbClr val="27AE60"/>
+                </a:solidFill>
+                <a:latin typeface="Calibri"/>
+              </a:rPr>
+              <a:t>+30.8% vs SVM ***</a:t>
+            </a:r>
+          </a:p>
+          <a:p>
+            <a:pPr algn="l">
+              <a:lnSpc>
+                <a:spcPct val="115000"/>
+              </a:lnSpc>
+              <a:spcBef>
+                <a:spcPts val="0"/>
+              </a:spcBef>
+              <a:spcAft>
                 <a:spcPts val="300"/>
               </a:spcAft>
+              <a:defRPr sz="1800" b="0">
+                <a:solidFill>
+                  <a:srgbClr val="27AE60"/>
+                </a:solidFill>
+                <a:latin typeface="Calibri"/>
+              </a:defRPr>
+            </a:pPr>
+            <a:r>
+              <a:t>     MCC=0.469  Acc=0.734</a:t>
+            </a:r>
+          </a:p>
+          <a:p>
+            <a:pPr algn="l">
+              <a:lnSpc>
+                <a:spcPct val="115000"/>
+              </a:lnSpc>
+              <a:spcBef>
+                <a:spcPts val="0"/>
+              </a:spcBef>
+              <a:spcAft>
+                <a:spcPts val="100"/>
+              </a:spcAft>
             </a:pPr>
             <a:r>
               <a:rPr sz="2200" b="1">
                 <a:solidFill>
-                  <a:srgbClr val="27AE60"/>
-                </a:solidFill>
-                <a:latin typeface="Calibri"/>
-              </a:rPr>
-              <a:t>★ Sol 1 (Cat A)   </a:t>
+                  <a:srgbClr val="E67E22"/>
+                </a:solidFill>
+                <a:latin typeface="Calibri"/>
+              </a:rPr>
+              <a:t>★ Sol 2 (Cat B)   </a:t>
             </a:r>
             <a:r>
               <a:rPr sz="2200" b="1">
                 <a:solidFill>
-                  <a:srgbClr val="27AE60"/>
-                </a:solidFill>
-                <a:latin typeface="Calibri"/>
-              </a:rPr>
-              <a:t>0.7340</a:t>
+                  <a:srgbClr val="E67E22"/>
+                </a:solidFill>
+                <a:latin typeface="Calibri"/>
+              </a:rPr>
+              <a:t>0.7422</a:t>
             </a:r>
             <a:r>
               <a:rPr sz="2200" b="0">
@@ -7745,11 +7816,11 @@
             <a:r>
               <a:rPr sz="2200" b="1">
                 <a:solidFill>
-                  <a:srgbClr val="27AE60"/>
-                </a:solidFill>
-                <a:latin typeface="Calibri"/>
-              </a:rPr>
-              <a:t>+30.8% vs SVM ***</a:t>
+                  <a:srgbClr val="E67E22"/>
+                </a:solidFill>
+                <a:latin typeface="Calibri"/>
+              </a:rPr>
+              <a:t>+19.2% vs LSTM ***</a:t>
             </a:r>
           </a:p>
           <a:p>
@@ -7761,44 +7832,17 @@
                 <a:spcPts val="0"/>
               </a:spcBef>
               <a:spcAft>
-                <a:spcPts val="400"/>
-              </a:spcAft>
-            </a:pPr>
-            <a:r>
-              <a:rPr sz="2200" b="1">
+                <a:spcPts val="300"/>
+              </a:spcAft>
+              <a:defRPr sz="1800" b="0">
                 <a:solidFill>
                   <a:srgbClr val="E67E22"/>
                 </a:solidFill>
                 <a:latin typeface="Calibri"/>
-              </a:rPr>
-              <a:t>★ Sol 2 (Cat B)   </a:t>
-            </a:r>
-            <a:r>
-              <a:rPr sz="2200" b="1">
-                <a:solidFill>
-                  <a:srgbClr val="E67E22"/>
-                </a:solidFill>
-                <a:latin typeface="Calibri"/>
-              </a:rPr>
-              <a:t>0.7422</a:t>
-            </a:r>
-            <a:r>
-              <a:rPr sz="2200" b="0">
-                <a:solidFill>
-                  <a:srgbClr val="2D2D2D"/>
-                </a:solidFill>
-                <a:latin typeface="Calibri"/>
-              </a:rPr>
-              <a:t>  </a:t>
-            </a:r>
-            <a:r>
-              <a:rPr sz="2200" b="1">
-                <a:solidFill>
-                  <a:srgbClr val="E67E22"/>
-                </a:solidFill>
-                <a:latin typeface="Calibri"/>
-              </a:rPr>
-              <a:t>+19.2% vs LSTM ***</a:t>
+              </a:defRPr>
+            </a:pPr>
+            <a:r>
+              <a:t>     MCC=0.485  Acc=0.742</a:t>
             </a:r>
           </a:p>
           <a:p>
@@ -7833,7 +7877,7 @@
         </p:nvSpPr>
         <p:spPr>
           <a:xfrm>
-            <a:off x="27419500" y="7450000"/>
+            <a:off x="27419500" y="7650000"/>
             <a:ext cx="8456500" cy="720000"/>
           </a:xfrm>
           <a:prstGeom prst="rect">
@@ -7876,7 +7920,7 @@
         </p:nvSpPr>
         <p:spPr>
           <a:xfrm>
-            <a:off x="27419500" y="7450000"/>
+            <a:off x="27419500" y="7650000"/>
             <a:ext cx="90000" cy="720000"/>
           </a:xfrm>
           <a:prstGeom prst="rect">
@@ -7919,7 +7963,7 @@
         </p:nvSpPr>
         <p:spPr>
           <a:xfrm>
-            <a:off x="27669500" y="7560000"/>
+            <a:off x="27669500" y="7760000"/>
             <a:ext cx="8106500" cy="500000"/>
           </a:xfrm>
           <a:prstGeom prst="rect">
@@ -7964,7 +8008,7 @@
         </p:nvSpPr>
         <p:spPr>
           <a:xfrm>
-            <a:off x="27419500" y="8120000"/>
+            <a:off x="27419500" y="8320000"/>
             <a:ext cx="8456500" cy="50000"/>
           </a:xfrm>
           <a:prstGeom prst="rect">
@@ -8007,7 +8051,7 @@
         </p:nvSpPr>
         <p:spPr>
           <a:xfrm>
-            <a:off x="27419500" y="8170000"/>
+            <a:off x="27419500" y="8370000"/>
             <a:ext cx="8456500" cy="3500000"/>
           </a:xfrm>
           <a:prstGeom prst="roundRect">
@@ -8062,7 +8106,7 @@
         </p:blipFill>
         <p:spPr>
           <a:xfrm>
-            <a:off x="27539500" y="8350000"/>
+            <a:off x="27539500" y="8550000"/>
             <a:ext cx="8216500" cy="3100000"/>
           </a:xfrm>
           <a:prstGeom prst="rect">
@@ -8078,7 +8122,7 @@
         </p:nvSpPr>
         <p:spPr>
           <a:xfrm>
-            <a:off x="27419500" y="11850000"/>
+            <a:off x="27419500" y="12050000"/>
             <a:ext cx="8456500" cy="720000"/>
           </a:xfrm>
           <a:prstGeom prst="rect">
@@ -8121,7 +8165,7 @@
         </p:nvSpPr>
         <p:spPr>
           <a:xfrm>
-            <a:off x="27419500" y="11850000"/>
+            <a:off x="27419500" y="12050000"/>
             <a:ext cx="90000" cy="720000"/>
           </a:xfrm>
           <a:prstGeom prst="rect">
@@ -8164,7 +8208,7 @@
         </p:nvSpPr>
         <p:spPr>
           <a:xfrm>
-            <a:off x="27669500" y="11960000"/>
+            <a:off x="27669500" y="12160000"/>
             <a:ext cx="8106500" cy="500000"/>
           </a:xfrm>
           <a:prstGeom prst="rect">
@@ -8209,7 +8253,7 @@
         </p:nvSpPr>
         <p:spPr>
           <a:xfrm>
-            <a:off x="27419500" y="12520000"/>
+            <a:off x="27419500" y="12720000"/>
             <a:ext cx="8456500" cy="50000"/>
           </a:xfrm>
           <a:prstGeom prst="rect">
@@ -8252,8 +8296,8 @@
         </p:nvSpPr>
         <p:spPr>
           <a:xfrm>
-            <a:off x="27419500" y="12570000"/>
-            <a:ext cx="8456500" cy="2900000"/>
+            <a:off x="27419500" y="12770000"/>
+            <a:ext cx="8456500" cy="2700000"/>
           </a:xfrm>
           <a:prstGeom prst="roundRect">
             <a:avLst>
@@ -8307,8 +8351,8 @@
         </p:blipFill>
         <p:spPr>
           <a:xfrm>
-            <a:off x="27479500" y="12720000"/>
-            <a:ext cx="8336500" cy="2600000"/>
+            <a:off x="27479500" y="12920000"/>
+            <a:ext cx="8336500" cy="2400000"/>
           </a:xfrm>
           <a:prstGeom prst="rect">
             <a:avLst/>

</xml_diff>